<commit_message>
Demo UI: shop, kitchen screen read from Solana, agent page for x402; hosted app and x402 service
Server-signed orders replace the in-memory store so the app can run on Vercel.
The kitchen reads the merchant's USDC account history and verifies each memo.
The x402 service runs the agent and reports each step for the page to animate.
e2e: 10/10 on devnet. Design files in design/.

Co-Authored-By: Claude Opus 5.5 <noreply@anthropic.com>
</commit_message>
<xml_diff>
--- a/deck/prompt-to-payments.pptx
+++ b/deck/prompt-to-payments.pptx
@@ -1174,7 +1174,7 @@
           <a:p>
             <a:r>
               <a:rPr lang="en-US" dirty="0"/>
-              <a:t>Run it live in the reference app folder: `npm run dev` in one terminal, `node scripts/e2e.ts` in another. It pays on devnet with your CLI wallet (~/.config/solana/id.json) and tries five attacks. All 7 checks passed on 19 Oct 2026.
+              <a:t>Run it live in the reference app folder: `npm run dev` in one terminal, `node scripts/e2e.ts` in another. It pays on devnet with your CLI wallet (~/.config/solana/id.json) and tries six attacks, then checks the kitchen. All 10 checks passed on 19 Oct 2026. Keep the kitchen screen open on the projector while it runs: the underpaid order shows up red and the refusals list fills.
 The receipt on the slide is the fallback if the network dies mid-demo.
 The habit to leave them with: "Write a script that tries to get this order marked paid without paying the full price." AI is very good at writing attacks. It's how you find out whether its own fix holds.</a:t>
             </a:r>
@@ -1636,7 +1636,7 @@
 - `curl -i` shows the 402 and the PAYMENT-REQUIRED header (base64 JSON). Decode it for the room: `curl -s -D - localhost:4021/proverb -o /dev/null | grep -i payment-required | cut -d' ' -f2 | tr -d '\r' | base64 -d`
 - The agent's wallet needs devnet USDC but no SOL. The x402.org facilitator pays the fee.
 - The merchant (PAY_TO) must already have a devnet USDC token account. The x402 Solana scheme doesn't let the payer create one.
-STATUS (19 Oct 2026): server and the 402 response tested. The paid retry was failing only because the agent wallet had 0 devnet USDC. TOBI: fund it and run this once before the day.
+STATUS (19 Oct 2026): the hosted service (mamaput-x402.vercel.app) and the hosted agent page are live and tested up to step 4. The paid retry fails only because the hosted agent wallet 9MKM8N5ZaFDhFave7SR2uS4cBHjURCXemJHdEQYSXP1k has 0 devnet USDC. TOBI: fund it at faucet.circle.com and press Run once before the day.
 Fallback slides with the decoded JSON, the server code and the agent code are in the backup deck (`npm run backup`, localhost:3031).</a:t>
             </a:r>
             <a:endParaRPr lang="en-US" dirty="0"/>

</xml_diff>